<commit_message>
airflow + llm monitoring
</commit_message>
<xml_diff>
--- a/docs/slide-deck/sentinel-proposal-deck.pptx
+++ b/docs/slide-deck/sentinel-proposal-deck.pptx
@@ -728,7 +728,7 @@
           <a:lstStyle/>
           <a:p>
             <a:r>
-              <a:t>Land the scalability story without internal targeting specifics. Progressive autonomy reassures: we don't ask for trust up front, we earn it.</a:t>
+              <a:t>Land the scalability story without internal targeting specifics. Progressive autonomy reassures: we don't ask for trust up front, we earn it. The Airflow DAG-failure and LLM-eval examples are especially apt for a data-science/AIOps buyer — and they also become monitoring surfaces in Mission Control (DAG stats, LLM eval-metric trends).</a:t>
             </a:r>
           </a:p>
         </p:txBody>
@@ -6669,7 +6669,7 @@
         </p:nvSpPr>
         <p:spPr>
           <a:xfrm>
-            <a:off x="640080" y="1737360"/>
+            <a:off x="640080" y="1691640"/>
             <a:ext cx="10972800" cy="4937760"/>
           </a:xfrm>
           <a:prstGeom prst="rect">
@@ -6688,7 +6688,7 @@
                 <a:spcPct val="105000"/>
               </a:lnSpc>
               <a:spcAft>
-                <a:spcPts val="1000"/>
+                <a:spcPts val="900"/>
               </a:spcAft>
             </a:pPr>
             <a:r>
@@ -6707,7 +6707,7 @@
                 <a:spcPct val="105000"/>
               </a:lnSpc>
               <a:spcAft>
-                <a:spcPts val="1000"/>
+                <a:spcPts val="900"/>
               </a:spcAft>
             </a:pPr>
             <a:r>
@@ -6717,7 +6717,7 @@
                 </a:solidFill>
                 <a:latin typeface="Calibri"/>
               </a:rPr>
-              <a:t>•  Start with Splunk-driven incidents on microservices; broaden to any incident type the queue receives.</a:t>
+              <a:t>•  Start with Splunk-driven incidents on microservices; broaden to any incident type — e.g. Airflow DAG/task failures, or LLM-output quality-metric alerts.</a:t>
             </a:r>
           </a:p>
           <a:p>
@@ -6726,7 +6726,7 @@
                 <a:spcPct val="105000"/>
               </a:lnSpc>
               <a:spcAft>
-                <a:spcPts val="1000"/>
+                <a:spcPts val="900"/>
               </a:spcAft>
             </a:pPr>
             <a:r>
@@ -6736,7 +6736,7 @@
                 </a:solidFill>
                 <a:latin typeface="Calibri"/>
               </a:rPr>
-              <a:t>•  Progressive autonomy — automation is earned: human-approved first, then opt-in auto-apply on lower-tier systems once the track record is proven (always audited and reversible).</a:t>
+              <a:t>•  Triggers generalise too — ServiceNow today; Airflow events and email alerts next.</a:t>
             </a:r>
           </a:p>
           <a:p>
@@ -6745,7 +6745,26 @@
                 <a:spcPct val="105000"/>
               </a:lnSpc>
               <a:spcAft>
-                <a:spcPts val="1000"/>
+                <a:spcPts val="900"/>
+              </a:spcAft>
+            </a:pPr>
+            <a:r>
+              <a:rPr sz="1800" b="0">
+                <a:solidFill>
+                  <a:srgbClr val="333F4A"/>
+                </a:solidFill>
+                <a:latin typeface="Calibri"/>
+              </a:rPr>
+              <a:t>•  Progressive autonomy — automation is earned: human-approved first, then opt-in auto-apply on lower-tier systems once the track record is proven (always audited and reversible).</a:t>
+            </a:r>
+          </a:p>
+          <a:p>
+            <a:pPr algn="l">
+              <a:lnSpc>
+                <a:spcPct val="105000"/>
+              </a:lnSpc>
+              <a:spcAft>
+                <a:spcPts val="900"/>
               </a:spcAft>
             </a:pPr>
             <a:r>

</xml_diff>